<commit_message>
CI: install metric-compatible fonts; assert deck findings instead of exit code; make the deck build reproducible
</commit_message>
<xml_diff>
--- a/corpus/deck.pptx
+++ b/corpus/deck.pptx
@@ -3971,9 +3971,9 @@
           <a:p>
             <a:r>
               <a:rPr sz="1800" b="0">
-                <a:latin typeface="Segoe UI"/>
+                <a:latin typeface="DocxIntegrity No Such Face"/>
               </a:rPr>
-              <a:t>Segoe UI sample text</a:t>
+              <a:t>Sample text in a face nobody has</a:t>
             </a:r>
           </a:p>
         </p:txBody>

</xml_diff>